<commit_message>
modified graphic creation and finalized poster
</commit_message>
<xml_diff>
--- a/HDSI Scholarship Project Poster.pptx
+++ b/HDSI Scholarship Project Poster.pptx
@@ -8,7 +8,7 @@
     <p:notesMasterId r:id="rId3"/>
   </p:notesMasterIdLst>
   <p:sldIdLst>
-    <p:sldId id="258" r:id="rId2"/>
+    <p:sldId id="261" r:id="rId2"/>
   </p:sldIdLst>
   <p:sldSz cx="43891200" cy="32918400"/>
   <p:notesSz cx="9144000" cy="6858000"/>
@@ -246,7 +246,7 @@
       <p15:sldGuideLst xmlns:p15="http://schemas.microsoft.com/office/powerpoint/2012/main"/>
     </p:ext>
     <p:ext uri="GoogleSlidesCustomDataVersion2">
-      <go:slidesCustomData xmlns="" xmlns:mc="http://schemas.openxmlformats.org/markup-compatibility/2006" xmlns:mv="urn:schemas-microsoft-com:mac:vml" xmlns:c="http://schemas.openxmlformats.org/drawingml/2006/chart" xmlns:dgm="http://schemas.openxmlformats.org/drawingml/2006/diagram" xmlns:o="urn:schemas-microsoft-com:office:office" xmlns:v="urn:schemas-microsoft-com:vml" xmlns:pvml="urn:schemas-microsoft-com:office:powerpoint" xmlns:com="http://schemas.openxmlformats.org/drawingml/2006/compatibility" xmlns:p14="http://schemas.microsoft.com/office/powerpoint/2010/main" xmlns:p15="http://schemas.microsoft.com/office/powerpoint/2012/main" xmlns:ahyp="http://schemas.microsoft.com/office/drawing/2018/hyperlinkcolor" xmlns:go="http://customooxmlschemas.google.com/" r:id="rId6" roundtripDataSignature="AMtx7mgMz+OWqnqH0Lk/xz1YeUwz86kd5A=="/>
+      <go:slidesCustomData xmlns:go="http://customooxmlschemas.google.com/" xmlns:ahyp="http://schemas.microsoft.com/office/drawing/2018/hyperlinkcolor" xmlns:p15="http://schemas.microsoft.com/office/powerpoint/2012/main" xmlns:p14="http://schemas.microsoft.com/office/powerpoint/2010/main" xmlns:com="http://schemas.openxmlformats.org/drawingml/2006/compatibility" xmlns:pvml="urn:schemas-microsoft-com:office:powerpoint" xmlns:v="urn:schemas-microsoft-com:vml" xmlns:o="urn:schemas-microsoft-com:office:office" xmlns:dgm="http://schemas.openxmlformats.org/drawingml/2006/diagram" xmlns:c="http://schemas.openxmlformats.org/drawingml/2006/chart" xmlns:mv="urn:schemas-microsoft-com:mac:vml" xmlns:mc="http://schemas.openxmlformats.org/markup-compatibility/2006" xmlns="" r:id="rId6" roundtripDataSignature="AMtx7mgMz+OWqnqH0Lk/xz1YeUwz86kd5A=="/>
     </p:ext>
   </p:extLst>
 </p:presentation>
@@ -701,7 +701,7 @@
         <p:cNvPr id="1" name="Shape 80">
           <a:extLst>
             <a:ext uri="{FF2B5EF4-FFF2-40B4-BE49-F238E27FC236}">
-              <a16:creationId xmlns:a16="http://schemas.microsoft.com/office/drawing/2014/main" id="{7D0FC1F0-BA80-8EBE-9CB8-AF814E03449A}"/>
+              <a16:creationId xmlns:a16="http://schemas.microsoft.com/office/drawing/2014/main" id="{6ECB715F-B2C6-3583-EEC7-6DC78D831A93}"/>
             </a:ext>
           </a:extLst>
         </p:cNvPr>
@@ -721,7 +721,7 @@
           <p:cNvPr id="81" name="Google Shape;81;p1:notes">
             <a:extLst>
               <a:ext uri="{FF2B5EF4-FFF2-40B4-BE49-F238E27FC236}">
-                <a16:creationId xmlns:a16="http://schemas.microsoft.com/office/drawing/2014/main" id="{D73DCAD4-B07F-A385-64BE-14BCBCD5DCC8}"/>
+                <a16:creationId xmlns:a16="http://schemas.microsoft.com/office/drawing/2014/main" id="{6E1146B1-76D6-20D7-4A66-14DE16D27361}"/>
               </a:ext>
             </a:extLst>
           </p:cNvPr>
@@ -765,7 +765,7 @@
           <p:cNvPr id="82" name="Google Shape;82;p1:notes">
             <a:extLst>
               <a:ext uri="{FF2B5EF4-FFF2-40B4-BE49-F238E27FC236}">
-                <a16:creationId xmlns:a16="http://schemas.microsoft.com/office/drawing/2014/main" id="{4CCCD70E-A630-47C1-CB3C-C63EEF7980CF}"/>
+                <a16:creationId xmlns:a16="http://schemas.microsoft.com/office/drawing/2014/main" id="{5FD3B780-E528-FD7D-5A5E-D6C058BF01C9}"/>
               </a:ext>
             </a:extLst>
           </p:cNvPr>
@@ -810,7 +810,7 @@
     </p:spTree>
     <p:extLst>
       <p:ext uri="{BB962C8B-B14F-4D97-AF65-F5344CB8AC3E}">
-        <p14:creationId xmlns:p14="http://schemas.microsoft.com/office/powerpoint/2010/main" val="2127519763"/>
+        <p14:creationId xmlns:p14="http://schemas.microsoft.com/office/powerpoint/2010/main" val="356379386"/>
       </p:ext>
     </p:extLst>
   </p:cSld>
@@ -11066,7 +11066,7 @@
         <p:cNvPr id="1" name="Shape 83">
           <a:extLst>
             <a:ext uri="{FF2B5EF4-FFF2-40B4-BE49-F238E27FC236}">
-              <a16:creationId xmlns:a16="http://schemas.microsoft.com/office/drawing/2014/main" id="{9206E2B0-7A60-36F8-49E4-FEF8AA121E81}"/>
+              <a16:creationId xmlns:a16="http://schemas.microsoft.com/office/drawing/2014/main" id="{529A38EA-A239-452F-7887-AA0BBF9239FF}"/>
             </a:ext>
           </a:extLst>
         </p:cNvPr>
@@ -11086,7 +11086,7 @@
           <p:cNvPr id="84" name="Google Shape;84;p1">
             <a:extLst>
               <a:ext uri="{FF2B5EF4-FFF2-40B4-BE49-F238E27FC236}">
-                <a16:creationId xmlns:a16="http://schemas.microsoft.com/office/drawing/2014/main" id="{B767F2BE-B069-A12C-8151-F07001676B11}"/>
+                <a16:creationId xmlns:a16="http://schemas.microsoft.com/office/drawing/2014/main" id="{BEAEA87C-7925-C68C-9FCD-4C1169069CEB}"/>
               </a:ext>
             </a:extLst>
           </p:cNvPr>
@@ -11119,7 +11119,7 @@
           <p:cNvPr id="85" name="Google Shape;85;p1">
             <a:extLst>
               <a:ext uri="{FF2B5EF4-FFF2-40B4-BE49-F238E27FC236}">
-                <a16:creationId xmlns:a16="http://schemas.microsoft.com/office/drawing/2014/main" id="{A2466B33-7B25-0EFD-8EE5-1C486517D218}"/>
+                <a16:creationId xmlns:a16="http://schemas.microsoft.com/office/drawing/2014/main" id="{DE7729E4-D866-9CBE-964F-97F88CD57CA8}"/>
               </a:ext>
             </a:extLst>
           </p:cNvPr>
@@ -11175,7 +11175,7 @@
           <p:cNvPr id="86" name="Google Shape;86;p1">
             <a:extLst>
               <a:ext uri="{FF2B5EF4-FFF2-40B4-BE49-F238E27FC236}">
-                <a16:creationId xmlns:a16="http://schemas.microsoft.com/office/drawing/2014/main" id="{AEC9ACF1-00AA-D1B7-8DD9-C81FCA04F692}"/>
+                <a16:creationId xmlns:a16="http://schemas.microsoft.com/office/drawing/2014/main" id="{D3210117-071B-8D6B-16A0-7FBCAAB412C5}"/>
               </a:ext>
             </a:extLst>
           </p:cNvPr>
@@ -11184,8 +11184,8 @@
         </p:nvSpPr>
         <p:spPr>
           <a:xfrm>
-            <a:off x="736419" y="3292101"/>
-            <a:ext cx="13397467" cy="8205243"/>
+            <a:off x="736419" y="3292102"/>
+            <a:ext cx="13397467" cy="7238246"/>
           </a:xfrm>
           <a:prstGeom prst="rect">
             <a:avLst/>
@@ -11286,7 +11286,7 @@
                 <a:ea typeface="Calibri"/>
                 <a:cs typeface="Calibri"/>
               </a:rPr>
-              <a:t>, </a:t>
+              <a:t> (Probability of shot being scored), </a:t>
             </a:r>
             <a:r>
               <a:rPr lang="en-US" sz="3600" dirty="0" err="1">
@@ -11308,15 +11308,8 @@
                 <a:ea typeface="Calibri"/>
                 <a:cs typeface="Calibri"/>
               </a:rPr>
-              <a:t>, and VAEP excel at modeling offensive contributions but struggle with defensive actions that prevent events rather than cause them. This work takes a counterfactual approach: measuring how a defender's action shifts danger relative to what was expected given the duel's context.</a:t>
+              <a:t> (Probability of scoring in next k actions), and VAEP (Change in probability of scoring) excel at modeling offensive contributions but struggle with defensive actions. Here, my work takes a counterfactual approach: measuring how a defender's action compares to the expected outcome.</a:t>
             </a:r>
-          </a:p>
-          <a:p>
-            <a:pPr marL="457200" lvl="1">
-              <a:spcAft>
-                <a:spcPts val="600"/>
-              </a:spcAft>
-            </a:pPr>
             <a:endParaRPr sz="3600" dirty="0">
               <a:solidFill>
                 <a:schemeClr val="bg2"/>
@@ -11381,7 +11374,7 @@
                 <a:cs typeface="Calibri"/>
                 <a:sym typeface="Calibri"/>
               </a:rPr>
-              <a:t>From observed defensive duels model defensive duel value as the expected danger minus the actual danger of the duel. </a:t>
+              <a:t>From observed defensive duels, model defensive duel value as the expected danger minus the actual danger of the duel. </a:t>
             </a:r>
             <a:endParaRPr sz="3600" dirty="0">
               <a:solidFill>
@@ -11399,7 +11392,7 @@
           <p:cNvPr id="87" name="Google Shape;87;p1">
             <a:extLst>
               <a:ext uri="{FF2B5EF4-FFF2-40B4-BE49-F238E27FC236}">
-                <a16:creationId xmlns:a16="http://schemas.microsoft.com/office/drawing/2014/main" id="{5B4C816C-9EC1-FD52-DEA9-BE360BBE9C54}"/>
+                <a16:creationId xmlns:a16="http://schemas.microsoft.com/office/drawing/2014/main" id="{BDD92D97-BB09-767B-9890-5265CCC14A7F}"/>
               </a:ext>
             </a:extLst>
           </p:cNvPr>
@@ -11469,7 +11462,7 @@
                 <a:cs typeface="Calibri"/>
                 <a:sym typeface="Calibri"/>
               </a:rPr>
-              <a:t>Estimating defensive duel value as expected danger – observed danger allows us to wholistic view about a player’s / team’s defensive capabilities for analysis and recruiting purposes.  We were also able to determine the factors that makes defensive duels difficult and dangerous. </a:t>
+              <a:t>Estimating defensive duel value as expected danger – observed danger gives us a wholistic view about a player’s / team’s defensive capabilities for analysis and recruiting purposes.  We were also able to determine the factors that makes defensive duels difficult and dangerous. </a:t>
             </a:r>
             <a:endParaRPr sz="3600" dirty="0">
               <a:solidFill>
@@ -11487,7 +11480,7 @@
           <p:cNvPr id="88" name="Google Shape;88;p1">
             <a:extLst>
               <a:ext uri="{FF2B5EF4-FFF2-40B4-BE49-F238E27FC236}">
-                <a16:creationId xmlns:a16="http://schemas.microsoft.com/office/drawing/2014/main" id="{44AF3202-106E-B913-976E-8401453854FB}"/>
+                <a16:creationId xmlns:a16="http://schemas.microsoft.com/office/drawing/2014/main" id="{8C200DFB-EEC2-359D-3B52-E314090FE151}"/>
               </a:ext>
             </a:extLst>
           </p:cNvPr>
@@ -11496,8 +11489,8 @@
         </p:nvSpPr>
         <p:spPr>
           <a:xfrm>
-            <a:off x="736418" y="20284161"/>
-            <a:ext cx="13397467" cy="9510255"/>
+            <a:off x="736418" y="20820926"/>
+            <a:ext cx="13397467" cy="8973490"/>
           </a:xfrm>
           <a:prstGeom prst="rect">
             <a:avLst/>
@@ -11517,7 +11510,7 @@
         </p:spPr>
         <p:txBody>
           <a:bodyPr spcFirstLastPara="1" wrap="square" lIns="91425" tIns="45700" rIns="91425" bIns="45700" anchor="t" anchorCtr="0">
-            <a:spAutoFit/>
+            <a:noAutofit/>
           </a:bodyPr>
           <a:lstStyle/>
           <a:p>
@@ -11655,26 +11648,6 @@
               <a:buNone/>
             </a:pPr>
             <a:endParaRPr sz="4320" dirty="0">
-              <a:solidFill>
-                <a:schemeClr val="lt1"/>
-              </a:solidFill>
-              <a:latin typeface="Calibri"/>
-              <a:ea typeface="Calibri"/>
-              <a:cs typeface="Calibri"/>
-              <a:sym typeface="Calibri"/>
-            </a:endParaRPr>
-          </a:p>
-          <a:p>
-            <a:pPr marL="0" marR="0" lvl="0" indent="0" algn="ctr" rtl="0">
-              <a:spcBef>
-                <a:spcPts val="0"/>
-              </a:spcBef>
-              <a:spcAft>
-                <a:spcPts val="0"/>
-              </a:spcAft>
-              <a:buNone/>
-            </a:pPr>
-            <a:endParaRPr lang="en-US" sz="4320" dirty="0">
               <a:solidFill>
                 <a:schemeClr val="lt1"/>
               </a:solidFill>
@@ -11783,7 +11756,7 @@
           <p:cNvPr id="89" name="Google Shape;89;p1">
             <a:extLst>
               <a:ext uri="{FF2B5EF4-FFF2-40B4-BE49-F238E27FC236}">
-                <a16:creationId xmlns:a16="http://schemas.microsoft.com/office/drawing/2014/main" id="{0B8E5B07-0971-6440-1C5C-FD8C05DABAFB}"/>
+                <a16:creationId xmlns:a16="http://schemas.microsoft.com/office/drawing/2014/main" id="{4B5A7F0C-78E0-0C62-1DE2-BE83A884DE5E}"/>
               </a:ext>
             </a:extLst>
           </p:cNvPr>
@@ -11792,8 +11765,8 @@
         </p:nvSpPr>
         <p:spPr>
           <a:xfrm>
-            <a:off x="736418" y="11923512"/>
-            <a:ext cx="13397467" cy="7934482"/>
+            <a:off x="736418" y="10956476"/>
+            <a:ext cx="13397467" cy="9438322"/>
           </a:xfrm>
           <a:prstGeom prst="rect">
             <a:avLst/>
@@ -11848,10 +11821,12 @@
             </a:r>
           </a:p>
           <a:p>
-            <a:pPr marL="457200">
+            <a:pPr marL="1028700" indent="-571500">
               <a:spcAft>
                 <a:spcPts val="600"/>
               </a:spcAft>
+              <a:buFont typeface="Arial" panose="020B0604020202020204" pitchFamily="34" charset="0"/>
+              <a:buChar char="•"/>
             </a:pPr>
             <a:r>
               <a:rPr lang="en-US" sz="3600" dirty="0">
@@ -11862,58 +11837,16 @@
                 <a:ea typeface="Calibri"/>
                 <a:cs typeface="Calibri"/>
               </a:rPr>
-              <a:t>Data from </a:t>
-            </a:r>
-            <a:r>
-              <a:rPr lang="en-US" sz="3600" b="1" dirty="0">
-                <a:solidFill>
-                  <a:schemeClr val="bg2"/>
-                </a:solidFill>
-                <a:latin typeface="Calibri"/>
-                <a:ea typeface="Calibri"/>
-                <a:cs typeface="Calibri"/>
-              </a:rPr>
-              <a:t>800k+ defensive duels </a:t>
-            </a:r>
-            <a:r>
-              <a:rPr lang="en-US" sz="3600" dirty="0">
-                <a:solidFill>
-                  <a:schemeClr val="bg2"/>
-                </a:solidFill>
-                <a:latin typeface="Calibri"/>
-                <a:ea typeface="Calibri"/>
-                <a:cs typeface="Calibri"/>
-              </a:rPr>
-              <a:t>across </a:t>
-            </a:r>
-            <a:r>
-              <a:rPr lang="en-US" sz="3600" b="1" dirty="0">
-                <a:solidFill>
-                  <a:schemeClr val="bg2"/>
-                </a:solidFill>
-                <a:latin typeface="Calibri"/>
-                <a:ea typeface="Calibri"/>
-                <a:cs typeface="Calibri"/>
-              </a:rPr>
-              <a:t>7k+ Wyscout matches </a:t>
-            </a:r>
-            <a:r>
-              <a:rPr lang="en-US" sz="3600" dirty="0">
-                <a:solidFill>
-                  <a:schemeClr val="bg2"/>
-                </a:solidFill>
-                <a:latin typeface="Calibri"/>
-                <a:ea typeface="Calibri"/>
-                <a:cs typeface="Calibri"/>
-              </a:rPr>
-              <a:t>were analyzed. For each duel, outcome and spatial features were extracted, and a binary danger label was assigned based on whether a goal was conceded within 20 seconds of the duel.</a:t>
+              <a:t>800k+ defensive duels across 7k+ D1 Wyscout matches.</a:t>
             </a:r>
           </a:p>
           <a:p>
-            <a:pPr marL="457200">
+            <a:pPr marL="1028700" indent="-571500">
               <a:spcAft>
                 <a:spcPts val="600"/>
               </a:spcAft>
+              <a:buFont typeface="Arial" panose="020B0604020202020204" pitchFamily="34" charset="0"/>
+              <a:buChar char="•"/>
             </a:pPr>
             <a:r>
               <a:rPr lang="en-US" sz="3600" dirty="0">
@@ -11924,14 +11857,16 @@
                 <a:ea typeface="Calibri"/>
                 <a:cs typeface="Calibri"/>
               </a:rPr>
-              <a:t>Three speed-of-play features captured pre-duel ball tempo: net x-displacement of the ball in the prior 30 seconds, total ball distance in the prior 30 seconds, and the ratio of ball distance over 30 vs. 60 seconds.</a:t>
+              <a:t>Derived play outcome as a goal being conceded within 20 sec.</a:t>
             </a:r>
           </a:p>
           <a:p>
-            <a:pPr marL="457200">
+            <a:pPr marL="1028700" indent="-571500">
               <a:spcAft>
                 <a:spcPts val="600"/>
               </a:spcAft>
+              <a:buFont typeface="Arial" panose="020B0604020202020204" pitchFamily="34" charset="0"/>
+              <a:buChar char="•"/>
             </a:pPr>
             <a:r>
               <a:rPr lang="en-US" sz="3600" dirty="0">
@@ -11942,108 +11877,128 @@
                 <a:ea typeface="Calibri"/>
                 <a:cs typeface="Calibri"/>
               </a:rPr>
-              <a:t>Trained two LGB models: one to predict the difficulty of the duel (outcome: beat, stopped, recovered), and one to predict the danger (goal conceded in next 20s). Each model is trained on the spatial and speed of play features with the supervised outcomes. </a:t>
+              <a:t>Engineered 3 speed of play features to capture context.</a:t>
             </a:r>
-            <a:endParaRPr sz="4320" dirty="0">
-              <a:solidFill>
-                <a:schemeClr val="lt1"/>
-              </a:solidFill>
-              <a:latin typeface="Calibri"/>
-              <a:ea typeface="Calibri"/>
-              <a:cs typeface="Calibri"/>
-              <a:sym typeface="Calibri"/>
-            </a:endParaRPr>
           </a:p>
           <a:p>
-            <a:pPr marL="0" marR="0" lvl="0" indent="0" algn="ctr" rtl="0">
-              <a:spcBef>
-                <a:spcPts val="0"/>
-              </a:spcBef>
-              <a:spcAft>
-                <a:spcPts val="0"/>
-              </a:spcAft>
-              <a:buNone/>
+            <a:pPr marL="1947672" lvl="2" indent="-571500">
+              <a:spcAft>
+                <a:spcPts val="600"/>
+              </a:spcAft>
+              <a:buFont typeface="Arial" panose="020B0604020202020204" pitchFamily="34" charset="0"/>
+              <a:buChar char="•"/>
             </a:pPr>
-            <a:endParaRPr sz="4320" dirty="0">
-              <a:solidFill>
-                <a:schemeClr val="lt1"/>
-              </a:solidFill>
-              <a:latin typeface="Calibri"/>
-              <a:ea typeface="Calibri"/>
-              <a:cs typeface="Calibri"/>
-              <a:sym typeface="Calibri"/>
-            </a:endParaRPr>
+            <a:r>
+              <a:rPr lang="en-US" sz="3600" dirty="0">
+                <a:solidFill>
+                  <a:schemeClr val="bg2"/>
+                </a:solidFill>
+                <a:latin typeface="Calibri"/>
+                <a:ea typeface="Calibri"/>
+                <a:cs typeface="Calibri"/>
+              </a:rPr>
+              <a:t>Ball Progression: Net displacement in x of the ball in past 30 sec.</a:t>
+            </a:r>
           </a:p>
           <a:p>
-            <a:pPr marL="0" marR="0" lvl="0" indent="0" algn="ctr" rtl="0">
-              <a:spcBef>
-                <a:spcPts val="0"/>
-              </a:spcBef>
-              <a:spcAft>
-                <a:spcPts val="0"/>
-              </a:spcAft>
-              <a:buNone/>
+            <a:pPr marL="1947672" lvl="2" indent="-571500">
+              <a:spcAft>
+                <a:spcPts val="600"/>
+              </a:spcAft>
+              <a:buFont typeface="Arial" panose="020B0604020202020204" pitchFamily="34" charset="0"/>
+              <a:buChar char="•"/>
             </a:pPr>
-            <a:endParaRPr sz="4320" dirty="0">
-              <a:solidFill>
-                <a:schemeClr val="lt1"/>
-              </a:solidFill>
-              <a:latin typeface="Calibri"/>
-              <a:ea typeface="Calibri"/>
-              <a:cs typeface="Calibri"/>
-              <a:sym typeface="Calibri"/>
-            </a:endParaRPr>
+            <a:r>
+              <a:rPr lang="en-US" sz="3600" dirty="0">
+                <a:solidFill>
+                  <a:schemeClr val="bg2"/>
+                </a:solidFill>
+                <a:latin typeface="Calibri"/>
+                <a:ea typeface="Calibri"/>
+                <a:cs typeface="Calibri"/>
+              </a:rPr>
+              <a:t>Ball Tempo: Total distance the ball travelled in past 30 sec.</a:t>
+            </a:r>
           </a:p>
           <a:p>
-            <a:pPr marL="0" marR="0" lvl="0" indent="0" algn="ctr" rtl="0">
-              <a:spcBef>
-                <a:spcPts val="0"/>
-              </a:spcBef>
-              <a:spcAft>
-                <a:spcPts val="0"/>
-              </a:spcAft>
-              <a:buNone/>
+            <a:pPr marL="1947672" lvl="2" indent="-571500">
+              <a:spcAft>
+                <a:spcPts val="600"/>
+              </a:spcAft>
+              <a:buFont typeface="Arial" panose="020B0604020202020204" pitchFamily="34" charset="0"/>
+              <a:buChar char="•"/>
             </a:pPr>
-            <a:endParaRPr sz="4320" dirty="0">
-              <a:solidFill>
-                <a:schemeClr val="lt1"/>
-              </a:solidFill>
-              <a:latin typeface="Calibri"/>
-              <a:ea typeface="Calibri"/>
-              <a:cs typeface="Calibri"/>
-              <a:sym typeface="Calibri"/>
-            </a:endParaRPr>
+            <a:r>
+              <a:rPr lang="en-US" sz="3600" dirty="0">
+                <a:solidFill>
+                  <a:schemeClr val="bg2"/>
+                </a:solidFill>
+                <a:latin typeface="Calibri"/>
+                <a:ea typeface="Calibri"/>
+                <a:cs typeface="Calibri"/>
+              </a:rPr>
+              <a:t>Change in Tempo: Ratio of ball travel distance in 30 sec over ball travel distance in 60 sec.</a:t>
+            </a:r>
           </a:p>
           <a:p>
-            <a:pPr marL="0" marR="0" lvl="0" indent="0" algn="ctr" rtl="0">
-              <a:spcBef>
-                <a:spcPts val="0"/>
-              </a:spcBef>
-              <a:spcAft>
-                <a:spcPts val="0"/>
-              </a:spcAft>
-              <a:buNone/>
+            <a:pPr marL="1028700" lvl="2" indent="-571500">
+              <a:spcAft>
+                <a:spcPts val="600"/>
+              </a:spcAft>
+              <a:buFont typeface="Arial" panose="020B0604020202020204" pitchFamily="34" charset="0"/>
+              <a:buChar char="•"/>
             </a:pPr>
-            <a:endParaRPr sz="4320" dirty="0">
-              <a:solidFill>
-                <a:schemeClr val="lt1"/>
-              </a:solidFill>
-              <a:latin typeface="Calibri"/>
-              <a:ea typeface="Calibri"/>
-              <a:cs typeface="Calibri"/>
-              <a:sym typeface="Calibri"/>
-            </a:endParaRPr>
+            <a:r>
+              <a:rPr lang="en-US" sz="3600" dirty="0">
+                <a:solidFill>
+                  <a:schemeClr val="bg2"/>
+                </a:solidFill>
+                <a:latin typeface="Calibri"/>
+                <a:ea typeface="Calibri"/>
+                <a:cs typeface="Calibri"/>
+              </a:rPr>
+              <a:t>Trained two light gradient boosting models given the spatial and speed of play features.</a:t>
+            </a:r>
           </a:p>
           <a:p>
-            <a:pPr marL="0" marR="0" lvl="0" indent="0" algn="ctr" rtl="0">
-              <a:spcBef>
-                <a:spcPts val="0"/>
-              </a:spcBef>
-              <a:spcAft>
-                <a:spcPts val="0"/>
-              </a:spcAft>
-              <a:buNone/>
+            <a:pPr marL="1947672" lvl="5" indent="-571500">
+              <a:spcAft>
+                <a:spcPts val="600"/>
+              </a:spcAft>
+              <a:buFont typeface="Arial" panose="020B0604020202020204" pitchFamily="34" charset="0"/>
+              <a:buChar char="•"/>
             </a:pPr>
+            <a:r>
+              <a:rPr lang="en-US" sz="3600" dirty="0">
+                <a:solidFill>
+                  <a:schemeClr val="bg2"/>
+                </a:solidFill>
+                <a:latin typeface="Calibri"/>
+                <a:ea typeface="Calibri"/>
+                <a:cs typeface="Calibri"/>
+              </a:rPr>
+              <a:t>First, to predict outcome of the duel (beat, stopped, recovered)</a:t>
+            </a:r>
+          </a:p>
+          <a:p>
+            <a:pPr marL="1947672" lvl="5" indent="-571500">
+              <a:spcAft>
+                <a:spcPts val="600"/>
+              </a:spcAft>
+              <a:buFont typeface="Arial" panose="020B0604020202020204" pitchFamily="34" charset="0"/>
+              <a:buChar char="•"/>
+            </a:pPr>
+            <a:r>
+              <a:rPr lang="en-US" sz="3600" dirty="0">
+                <a:solidFill>
+                  <a:schemeClr val="bg2"/>
+                </a:solidFill>
+                <a:latin typeface="Calibri"/>
+                <a:ea typeface="Calibri"/>
+                <a:cs typeface="Calibri"/>
+              </a:rPr>
+              <a:t>Second, to predict danger of the duel (goal conceded in 20s)</a:t>
+            </a:r>
             <a:endParaRPr sz="4320" dirty="0">
               <a:solidFill>
                 <a:schemeClr val="lt1"/>
@@ -12081,7 +12036,7 @@
           <p:cNvPr id="90" name="Google Shape;90;p1">
             <a:extLst>
               <a:ext uri="{FF2B5EF4-FFF2-40B4-BE49-F238E27FC236}">
-                <a16:creationId xmlns:a16="http://schemas.microsoft.com/office/drawing/2014/main" id="{8ADCBF8C-1976-38F4-5961-25F8090B1C14}"/>
+                <a16:creationId xmlns:a16="http://schemas.microsoft.com/office/drawing/2014/main" id="{5F4E388E-A389-13FD-737F-4D0D71FF78A4}"/>
               </a:ext>
             </a:extLst>
           </p:cNvPr>
@@ -12507,7 +12462,7 @@
                 <a:cs typeface="Calibri"/>
                 <a:sym typeface="Calibri"/>
               </a:rPr>
-              <a:t>Duels at the corners of the 18 are significantly more difficult (~15%)</a:t>
+              <a:t>Duels at the corners of the 18 are significantly more difficult (~15%).</a:t>
             </a:r>
           </a:p>
           <a:p>
@@ -12531,7 +12486,7 @@
                 <a:cs typeface="Calibri"/>
                 <a:sym typeface="Calibri"/>
               </a:rPr>
-              <a:t>Losing duels in the box is extremely dangerous</a:t>
+              <a:t>Losing duels in the box is extremely dangerous.</a:t>
             </a:r>
           </a:p>
           <a:p>
@@ -12680,7 +12635,7 @@
           <p:cNvPr id="91" name="Google Shape;91;p1">
             <a:extLst>
               <a:ext uri="{FF2B5EF4-FFF2-40B4-BE49-F238E27FC236}">
-                <a16:creationId xmlns:a16="http://schemas.microsoft.com/office/drawing/2014/main" id="{A9C94B31-D4CC-8A90-63B6-6BA5146F73E6}"/>
+                <a16:creationId xmlns:a16="http://schemas.microsoft.com/office/drawing/2014/main" id="{6F197A9B-7A72-A03C-0118-C4CA4B9A9CD6}"/>
               </a:ext>
             </a:extLst>
           </p:cNvPr>
@@ -12752,7 +12707,7 @@
           <p:cNvPr id="92" name="Google Shape;92;p1">
             <a:extLst>
               <a:ext uri="{FF2B5EF4-FFF2-40B4-BE49-F238E27FC236}">
-                <a16:creationId xmlns:a16="http://schemas.microsoft.com/office/drawing/2014/main" id="{EF3C1CDA-87D5-B7A2-866A-418241138C50}"/>
+                <a16:creationId xmlns:a16="http://schemas.microsoft.com/office/drawing/2014/main" id="{2402D659-48F7-77A2-205F-6D48ACF47922}"/>
               </a:ext>
             </a:extLst>
           </p:cNvPr>
@@ -12811,208 +12766,12 @@
           </a:p>
         </p:txBody>
       </p:sp>
-      <p:pic>
-        <p:nvPicPr>
-          <p:cNvPr id="101" name="Google Shape;101;p1" title="p_outcome_panel_sop.png">
-            <a:extLst>
-              <a:ext uri="{FF2B5EF4-FFF2-40B4-BE49-F238E27FC236}">
-                <a16:creationId xmlns:a16="http://schemas.microsoft.com/office/drawing/2014/main" id="{0443F45E-73C5-78F0-49FF-EBD420802B78}"/>
-              </a:ext>
-            </a:extLst>
-          </p:cNvPr>
-          <p:cNvPicPr preferRelativeResize="0"/>
-          <p:nvPr/>
-        </p:nvPicPr>
-        <p:blipFill>
-          <a:blip r:embed="rId5">
-            <a:alphaModFix/>
-          </a:blip>
-          <a:stretch>
-            <a:fillRect/>
-          </a:stretch>
-        </p:blipFill>
-        <p:spPr>
-          <a:xfrm>
-            <a:off x="14559700" y="3292112"/>
-            <a:ext cx="15489377" cy="4734524"/>
-          </a:xfrm>
-          <a:prstGeom prst="rect">
-            <a:avLst/>
-          </a:prstGeom>
-          <a:noFill/>
-          <a:ln>
-            <a:noFill/>
-          </a:ln>
-        </p:spPr>
-      </p:pic>
-      <p:pic>
-        <p:nvPicPr>
-          <p:cNvPr id="104" name="Google Shape;104;p1" title="p_goal_panel_sop.png">
-            <a:extLst>
-              <a:ext uri="{FF2B5EF4-FFF2-40B4-BE49-F238E27FC236}">
-                <a16:creationId xmlns:a16="http://schemas.microsoft.com/office/drawing/2014/main" id="{3FB069AB-09DA-574B-8166-5BAF1E1941C0}"/>
-              </a:ext>
-            </a:extLst>
-          </p:cNvPr>
-          <p:cNvPicPr preferRelativeResize="0"/>
-          <p:nvPr/>
-        </p:nvPicPr>
-        <p:blipFill>
-          <a:blip r:embed="rId6">
-            <a:alphaModFix/>
-          </a:blip>
-          <a:stretch>
-            <a:fillRect/>
-          </a:stretch>
-        </p:blipFill>
-        <p:spPr>
-          <a:xfrm>
-            <a:off x="14559379" y="10239769"/>
-            <a:ext cx="15488701" cy="4643575"/>
-          </a:xfrm>
-          <a:prstGeom prst="rect">
-            <a:avLst/>
-          </a:prstGeom>
-          <a:noFill/>
-          <a:ln>
-            <a:noFill/>
-          </a:ln>
-        </p:spPr>
-      </p:pic>
-      <p:pic>
-        <p:nvPicPr>
-          <p:cNvPr id="3" name="Picture 2">
-            <a:extLst>
-              <a:ext uri="{FF2B5EF4-FFF2-40B4-BE49-F238E27FC236}">
-                <a16:creationId xmlns:a16="http://schemas.microsoft.com/office/drawing/2014/main" id="{08C26290-9AA6-D9AC-D11E-191E82794B2A}"/>
-              </a:ext>
-            </a:extLst>
-          </p:cNvPr>
-          <p:cNvPicPr>
-            <a:picLocks noChangeAspect="1"/>
-          </p:cNvPicPr>
-          <p:nvPr/>
-        </p:nvPicPr>
-        <p:blipFill>
-          <a:blip r:embed="rId7"/>
-          <a:stretch>
-            <a:fillRect/>
-          </a:stretch>
-        </p:blipFill>
-        <p:spPr>
-          <a:xfrm>
-            <a:off x="14559379" y="17135242"/>
-            <a:ext cx="15489069" cy="4643575"/>
-          </a:xfrm>
-          <a:prstGeom prst="rect">
-            <a:avLst/>
-          </a:prstGeom>
-        </p:spPr>
-      </p:pic>
-      <p:sp>
-        <p:nvSpPr>
-          <p:cNvPr id="5" name="Arrow: Down 4">
-            <a:extLst>
-              <a:ext uri="{FF2B5EF4-FFF2-40B4-BE49-F238E27FC236}">
-                <a16:creationId xmlns:a16="http://schemas.microsoft.com/office/drawing/2014/main" id="{A74A2F6A-3566-A860-DF7F-5CE5AD02F501}"/>
-              </a:ext>
-            </a:extLst>
-          </p:cNvPr>
-          <p:cNvSpPr/>
-          <p:nvPr/>
-        </p:nvSpPr>
-        <p:spPr>
-          <a:xfrm>
-            <a:off x="21118286" y="15164602"/>
-            <a:ext cx="1654628" cy="1689382"/>
-          </a:xfrm>
-          <a:prstGeom prst="downArrow">
-            <a:avLst/>
-          </a:prstGeom>
-          <a:solidFill>
-            <a:schemeClr val="bg1"/>
-          </a:solidFill>
-        </p:spPr>
-        <p:style>
-          <a:lnRef idx="2">
-            <a:schemeClr val="accent1">
-              <a:shade val="15000"/>
-            </a:schemeClr>
-          </a:lnRef>
-          <a:fillRef idx="1">
-            <a:schemeClr val="accent1"/>
-          </a:fillRef>
-          <a:effectRef idx="0">
-            <a:schemeClr val="accent1"/>
-          </a:effectRef>
-          <a:fontRef idx="minor">
-            <a:schemeClr val="lt1"/>
-          </a:fontRef>
-        </p:style>
-        <p:txBody>
-          <a:bodyPr rtlCol="0" anchor="ctr"/>
-          <a:lstStyle/>
-          <a:p>
-            <a:pPr algn="ctr"/>
-            <a:endParaRPr lang="en-US"/>
-          </a:p>
-        </p:txBody>
-      </p:sp>
-      <p:sp>
-        <p:nvSpPr>
-          <p:cNvPr id="6" name="Plus Sign 5">
-            <a:extLst>
-              <a:ext uri="{FF2B5EF4-FFF2-40B4-BE49-F238E27FC236}">
-                <a16:creationId xmlns:a16="http://schemas.microsoft.com/office/drawing/2014/main" id="{34E67565-364C-6873-369E-3A08AC7D1B26}"/>
-              </a:ext>
-            </a:extLst>
-          </p:cNvPr>
-          <p:cNvSpPr/>
-          <p:nvPr/>
-        </p:nvSpPr>
-        <p:spPr>
-          <a:xfrm>
-            <a:off x="20965886" y="8123424"/>
-            <a:ext cx="1959428" cy="1939293"/>
-          </a:xfrm>
-          <a:prstGeom prst="mathPlus">
-            <a:avLst/>
-          </a:prstGeom>
-          <a:solidFill>
-            <a:schemeClr val="bg1"/>
-          </a:solidFill>
-        </p:spPr>
-        <p:style>
-          <a:lnRef idx="2">
-            <a:schemeClr val="accent1">
-              <a:shade val="15000"/>
-            </a:schemeClr>
-          </a:lnRef>
-          <a:fillRef idx="1">
-            <a:schemeClr val="accent1"/>
-          </a:fillRef>
-          <a:effectRef idx="0">
-            <a:schemeClr val="accent1"/>
-          </a:effectRef>
-          <a:fontRef idx="minor">
-            <a:schemeClr val="lt1"/>
-          </a:fontRef>
-        </p:style>
-        <p:txBody>
-          <a:bodyPr rtlCol="0" anchor="ctr"/>
-          <a:lstStyle/>
-          <a:p>
-            <a:pPr algn="ctr"/>
-            <a:endParaRPr lang="en-US"/>
-          </a:p>
-        </p:txBody>
-      </p:sp>
       <p:sp>
         <p:nvSpPr>
           <p:cNvPr id="7" name="Google Shape;91;p1">
             <a:extLst>
               <a:ext uri="{FF2B5EF4-FFF2-40B4-BE49-F238E27FC236}">
-                <a16:creationId xmlns:a16="http://schemas.microsoft.com/office/drawing/2014/main" id="{37DA6468-63BB-2B2E-3CB8-95FD51E7D98A}"/>
+                <a16:creationId xmlns:a16="http://schemas.microsoft.com/office/drawing/2014/main" id="{6CB9A6EC-B8F4-41F3-8F7C-DDFFED46D39D}"/>
               </a:ext>
             </a:extLst>
           </p:cNvPr>
@@ -13044,7 +12803,7 @@
                 <a:solidFill>
                   <a:schemeClr val="bg1"/>
                 </a:solidFill>
-                <a:hlinkClick r:id="rId8">
+                <a:hlinkClick r:id="rId5">
                   <a:extLst>
                     <a:ext uri="{A12FA001-AC4F-418D-AE19-62706E023703}">
                       <ahyp:hlinkClr xmlns:ahyp="http://schemas.microsoft.com/office/drawing/2018/hyperlinkcolor" val="tx"/>
@@ -13067,7 +12826,7 @@
           <p:cNvPr id="12" name="Picture 11">
             <a:extLst>
               <a:ext uri="{FF2B5EF4-FFF2-40B4-BE49-F238E27FC236}">
-                <a16:creationId xmlns:a16="http://schemas.microsoft.com/office/drawing/2014/main" id="{07C2349E-2673-AFA9-572F-39694D0E9B12}"/>
+                <a16:creationId xmlns:a16="http://schemas.microsoft.com/office/drawing/2014/main" id="{51E3AFAC-6AC9-4B0C-BABC-0AB23DFD904D}"/>
               </a:ext>
             </a:extLst>
           </p:cNvPr>
@@ -13077,7 +12836,7 @@
           <p:nvPr/>
         </p:nvPicPr>
         <p:blipFill>
-          <a:blip r:embed="rId9"/>
+          <a:blip r:embed="rId6"/>
           <a:stretch>
             <a:fillRect/>
           </a:stretch>
@@ -13097,7 +12856,7 @@
           <p:cNvPr id="26" name="Group 25">
             <a:extLst>
               <a:ext uri="{FF2B5EF4-FFF2-40B4-BE49-F238E27FC236}">
-                <a16:creationId xmlns:a16="http://schemas.microsoft.com/office/drawing/2014/main" id="{04316DAB-2E1F-FF17-B06E-7E98D57B03EE}"/>
+                <a16:creationId xmlns:a16="http://schemas.microsoft.com/office/drawing/2014/main" id="{EAD4FD7D-1B05-3D5A-C45A-683F8E0433DA}"/>
               </a:ext>
             </a:extLst>
           </p:cNvPr>
@@ -13106,7 +12865,7 @@
         </p:nvGrpSpPr>
         <p:grpSpPr>
           <a:xfrm>
-            <a:off x="1429117" y="21947057"/>
+            <a:off x="1429117" y="22216804"/>
             <a:ext cx="12012067" cy="3916539"/>
             <a:chOff x="1429117" y="21312458"/>
             <a:chExt cx="12012067" cy="3916539"/>
@@ -13117,7 +12876,7 @@
             <p:cNvPr id="16" name="Picture 15">
               <a:extLst>
                 <a:ext uri="{FF2B5EF4-FFF2-40B4-BE49-F238E27FC236}">
-                  <a16:creationId xmlns:a16="http://schemas.microsoft.com/office/drawing/2014/main" id="{21C624F6-3A46-A039-A4C1-4D2FE363B681}"/>
+                  <a16:creationId xmlns:a16="http://schemas.microsoft.com/office/drawing/2014/main" id="{2E253545-ADB8-EF6D-6D02-6D579DB92042}"/>
                 </a:ext>
               </a:extLst>
             </p:cNvPr>
@@ -13127,7 +12886,7 @@
             <p:nvPr/>
           </p:nvPicPr>
           <p:blipFill>
-            <a:blip r:embed="rId10"/>
+            <a:blip r:embed="rId7"/>
             <a:stretch>
               <a:fillRect/>
             </a:stretch>
@@ -13147,7 +12906,7 @@
             <p:cNvPr id="18" name="Picture 17">
               <a:extLst>
                 <a:ext uri="{FF2B5EF4-FFF2-40B4-BE49-F238E27FC236}">
-                  <a16:creationId xmlns:a16="http://schemas.microsoft.com/office/drawing/2014/main" id="{A3329C36-E66A-68BD-B1A8-869C5758AA4B}"/>
+                  <a16:creationId xmlns:a16="http://schemas.microsoft.com/office/drawing/2014/main" id="{C86E5D84-01B5-7917-81D9-78DCD59D5CCF}"/>
                 </a:ext>
               </a:extLst>
             </p:cNvPr>
@@ -13157,7 +12916,7 @@
             <p:nvPr/>
           </p:nvPicPr>
           <p:blipFill>
-            <a:blip r:embed="rId11"/>
+            <a:blip r:embed="rId8"/>
             <a:stretch>
               <a:fillRect/>
             </a:stretch>
@@ -13177,7 +12936,7 @@
             <p:cNvPr id="20" name="Picture 19">
               <a:extLst>
                 <a:ext uri="{FF2B5EF4-FFF2-40B4-BE49-F238E27FC236}">
-                  <a16:creationId xmlns:a16="http://schemas.microsoft.com/office/drawing/2014/main" id="{6CD0C22B-D7FF-4FFE-C04A-6458562109F7}"/>
+                  <a16:creationId xmlns:a16="http://schemas.microsoft.com/office/drawing/2014/main" id="{2BB6C92F-4548-950E-5D08-955257E53A14}"/>
                 </a:ext>
               </a:extLst>
             </p:cNvPr>
@@ -13187,7 +12946,7 @@
             <p:nvPr/>
           </p:nvPicPr>
           <p:blipFill>
-            <a:blip r:embed="rId12"/>
+            <a:blip r:embed="rId9"/>
             <a:stretch>
               <a:fillRect/>
             </a:stretch>
@@ -13208,7 +12967,7 @@
           <p:cNvPr id="21" name="Google Shape;90;p1">
             <a:extLst>
               <a:ext uri="{FF2B5EF4-FFF2-40B4-BE49-F238E27FC236}">
-                <a16:creationId xmlns:a16="http://schemas.microsoft.com/office/drawing/2014/main" id="{03F9F441-24A4-53A4-04AF-F1C328EEBB71}"/>
+                <a16:creationId xmlns:a16="http://schemas.microsoft.com/office/drawing/2014/main" id="{ECADE1E4-CFFC-7506-2A40-A869F671FADD}"/>
               </a:ext>
             </a:extLst>
           </p:cNvPr>
@@ -13284,7 +13043,7 @@
                 <a:cs typeface="Calibri"/>
                 <a:sym typeface="Calibri"/>
               </a:rPr>
-              <a:t>Where most duel value comes from each outcome.</a:t>
+              <a:t>From all 800k duels which actions have the most defensive duel value given the defenders outcome.</a:t>
             </a:r>
             <a:endParaRPr lang="en-US" sz="6000" dirty="0">
               <a:solidFill>
@@ -13300,10 +13059,10 @@
       </p:sp>
       <p:pic>
         <p:nvPicPr>
-          <p:cNvPr id="25" name="Picture 24">
+          <p:cNvPr id="28" name="Picture 27">
             <a:extLst>
               <a:ext uri="{FF2B5EF4-FFF2-40B4-BE49-F238E27FC236}">
-                <a16:creationId xmlns:a16="http://schemas.microsoft.com/office/drawing/2014/main" id="{135318F2-E26A-BB0B-F716-011C5D510C7B}"/>
+                <a16:creationId xmlns:a16="http://schemas.microsoft.com/office/drawing/2014/main" id="{C37B2385-4986-0CA5-A551-CB84D5E0081E}"/>
               </a:ext>
             </a:extLst>
           </p:cNvPr>
@@ -13313,37 +13072,7 @@
           <p:nvPr/>
         </p:nvPicPr>
         <p:blipFill>
-          <a:blip r:embed="rId13"/>
-          <a:stretch>
-            <a:fillRect/>
-          </a:stretch>
-        </p:blipFill>
-        <p:spPr>
-          <a:xfrm>
-            <a:off x="14559379" y="25336063"/>
-            <a:ext cx="15565800" cy="4400975"/>
-          </a:xfrm>
-          <a:prstGeom prst="rect">
-            <a:avLst/>
-          </a:prstGeom>
-        </p:spPr>
-      </p:pic>
-      <p:pic>
-        <p:nvPicPr>
-          <p:cNvPr id="28" name="Picture 27">
-            <a:extLst>
-              <a:ext uri="{FF2B5EF4-FFF2-40B4-BE49-F238E27FC236}">
-                <a16:creationId xmlns:a16="http://schemas.microsoft.com/office/drawing/2014/main" id="{4B896B68-EE3E-8AF9-2F4B-9DA4DD6E8B90}"/>
-              </a:ext>
-            </a:extLst>
-          </p:cNvPr>
-          <p:cNvPicPr>
-            <a:picLocks noChangeAspect="1"/>
-          </p:cNvPicPr>
-          <p:nvPr/>
-        </p:nvPicPr>
-        <p:blipFill>
-          <a:blip r:embed="rId14"/>
+          <a:blip r:embed="rId10"/>
           <a:stretch>
             <a:fillRect/>
           </a:stretch>
@@ -13358,268 +13087,19 @@
           </a:prstGeom>
         </p:spPr>
       </p:pic>
-      <p:grpSp>
-        <p:nvGrpSpPr>
-          <p:cNvPr id="2" name="Group 1">
-            <a:extLst>
-              <a:ext uri="{FF2B5EF4-FFF2-40B4-BE49-F238E27FC236}">
-                <a16:creationId xmlns:a16="http://schemas.microsoft.com/office/drawing/2014/main" id="{791D23B4-5C9B-FE29-56A3-E077708E6F57}"/>
-              </a:ext>
-            </a:extLst>
-          </p:cNvPr>
-          <p:cNvGrpSpPr/>
-          <p:nvPr/>
-        </p:nvGrpSpPr>
-        <p:grpSpPr>
-          <a:xfrm>
-            <a:off x="30779709" y="5998502"/>
-            <a:ext cx="11903177" cy="6991653"/>
-            <a:chOff x="30779709" y="6509232"/>
-            <a:chExt cx="11903177" cy="6991653"/>
-          </a:xfrm>
-        </p:grpSpPr>
-        <p:grpSp>
-          <p:nvGrpSpPr>
-            <p:cNvPr id="15" name="Group 14">
-              <a:extLst>
-                <a:ext uri="{FF2B5EF4-FFF2-40B4-BE49-F238E27FC236}">
-                  <a16:creationId xmlns:a16="http://schemas.microsoft.com/office/drawing/2014/main" id="{32E586D8-919E-E297-83BC-5C1B74735DC1}"/>
-                </a:ext>
-              </a:extLst>
-            </p:cNvPr>
-            <p:cNvGrpSpPr/>
-            <p:nvPr/>
-          </p:nvGrpSpPr>
-          <p:grpSpPr>
-            <a:xfrm>
-              <a:off x="30779709" y="6509232"/>
-              <a:ext cx="11903177" cy="3814064"/>
-              <a:chOff x="30779709" y="6509232"/>
-              <a:chExt cx="18259081" cy="5850648"/>
-            </a:xfrm>
-          </p:grpSpPr>
-          <p:pic>
-            <p:nvPicPr>
-              <p:cNvPr id="30" name="Picture 29">
-                <a:extLst>
-                  <a:ext uri="{FF2B5EF4-FFF2-40B4-BE49-F238E27FC236}">
-                    <a16:creationId xmlns:a16="http://schemas.microsoft.com/office/drawing/2014/main" id="{41729166-496F-BC2B-8BAF-4D8A64EC128B}"/>
-                  </a:ext>
-                </a:extLst>
-              </p:cNvPr>
-              <p:cNvPicPr>
-                <a:picLocks noChangeAspect="1"/>
-              </p:cNvPicPr>
-              <p:nvPr/>
-            </p:nvPicPr>
-            <p:blipFill>
-              <a:blip r:embed="rId15"/>
-              <a:stretch>
-                <a:fillRect/>
-              </a:stretch>
-            </p:blipFill>
-            <p:spPr>
-              <a:xfrm>
-                <a:off x="30779709" y="6509232"/>
-                <a:ext cx="5090170" cy="5850648"/>
-              </a:xfrm>
-              <a:prstGeom prst="rect">
-                <a:avLst/>
-              </a:prstGeom>
-            </p:spPr>
-          </p:pic>
-          <p:pic>
-            <p:nvPicPr>
-              <p:cNvPr id="11" name="Picture 10">
-                <a:extLst>
-                  <a:ext uri="{FF2B5EF4-FFF2-40B4-BE49-F238E27FC236}">
-                    <a16:creationId xmlns:a16="http://schemas.microsoft.com/office/drawing/2014/main" id="{B5D42AB7-ECC8-BFB6-3870-44853F8D062C}"/>
-                  </a:ext>
-                </a:extLst>
-              </p:cNvPr>
-              <p:cNvPicPr>
-                <a:picLocks noChangeAspect="1"/>
-              </p:cNvPicPr>
-              <p:nvPr/>
-            </p:nvPicPr>
-            <p:blipFill>
-              <a:blip r:embed="rId16"/>
-              <a:stretch>
-                <a:fillRect/>
-              </a:stretch>
-            </p:blipFill>
-            <p:spPr>
-              <a:xfrm>
-                <a:off x="35869879" y="6509232"/>
-                <a:ext cx="5865888" cy="5850648"/>
-              </a:xfrm>
-              <a:prstGeom prst="rect">
-                <a:avLst/>
-              </a:prstGeom>
-            </p:spPr>
-          </p:pic>
-          <p:pic>
-            <p:nvPicPr>
-              <p:cNvPr id="14" name="Picture 13">
-                <a:extLst>
-                  <a:ext uri="{FF2B5EF4-FFF2-40B4-BE49-F238E27FC236}">
-                    <a16:creationId xmlns:a16="http://schemas.microsoft.com/office/drawing/2014/main" id="{3EF4E221-8E26-9049-B67C-80FEF334B177}"/>
-                  </a:ext>
-                </a:extLst>
-              </p:cNvPr>
-              <p:cNvPicPr>
-                <a:picLocks noChangeAspect="1"/>
-              </p:cNvPicPr>
-              <p:nvPr/>
-            </p:nvPicPr>
-            <p:blipFill>
-              <a:blip r:embed="rId17"/>
-              <a:stretch>
-                <a:fillRect/>
-              </a:stretch>
-            </p:blipFill>
-            <p:spPr>
-              <a:xfrm>
-                <a:off x="41735767" y="6509232"/>
-                <a:ext cx="7303023" cy="5850648"/>
-              </a:xfrm>
-              <a:prstGeom prst="rect">
-                <a:avLst/>
-              </a:prstGeom>
-            </p:spPr>
-          </p:pic>
-        </p:grpSp>
-        <p:grpSp>
-          <p:nvGrpSpPr>
-            <p:cNvPr id="32" name="Group 31">
-              <a:extLst>
-                <a:ext uri="{FF2B5EF4-FFF2-40B4-BE49-F238E27FC236}">
-                  <a16:creationId xmlns:a16="http://schemas.microsoft.com/office/drawing/2014/main" id="{A46E4706-653A-C863-0133-E314E970CFFD}"/>
-                </a:ext>
-              </a:extLst>
-            </p:cNvPr>
-            <p:cNvGrpSpPr/>
-            <p:nvPr/>
-          </p:nvGrpSpPr>
-          <p:grpSpPr>
-            <a:xfrm>
-              <a:off x="30779709" y="10323297"/>
-              <a:ext cx="11903177" cy="3177588"/>
-              <a:chOff x="28184968" y="13194897"/>
-              <a:chExt cx="21927820" cy="5853696"/>
-            </a:xfrm>
-          </p:grpSpPr>
-          <p:pic>
-            <p:nvPicPr>
-              <p:cNvPr id="23" name="Picture 22">
-                <a:extLst>
-                  <a:ext uri="{FF2B5EF4-FFF2-40B4-BE49-F238E27FC236}">
-                    <a16:creationId xmlns:a16="http://schemas.microsoft.com/office/drawing/2014/main" id="{7B2AF227-8DFB-5153-F6A9-42A3AF5AF470}"/>
-                  </a:ext>
-                </a:extLst>
-              </p:cNvPr>
-              <p:cNvPicPr>
-                <a:picLocks noChangeAspect="1"/>
-              </p:cNvPicPr>
-              <p:nvPr/>
-            </p:nvPicPr>
-            <p:blipFill>
-              <a:blip r:embed="rId18"/>
-              <a:stretch>
-                <a:fillRect/>
-              </a:stretch>
-            </p:blipFill>
-            <p:spPr>
-              <a:xfrm>
-                <a:off x="34151904" y="13194897"/>
-                <a:ext cx="6891542" cy="5853696"/>
-              </a:xfrm>
-              <a:prstGeom prst="rect">
-                <a:avLst/>
-              </a:prstGeom>
-            </p:spPr>
-          </p:pic>
-          <p:pic>
-            <p:nvPicPr>
-              <p:cNvPr id="27" name="Picture 26">
-                <a:extLst>
-                  <a:ext uri="{FF2B5EF4-FFF2-40B4-BE49-F238E27FC236}">
-                    <a16:creationId xmlns:a16="http://schemas.microsoft.com/office/drawing/2014/main" id="{A5A631A9-589F-EE30-A07D-FBD6A7835C33}"/>
-                  </a:ext>
-                </a:extLst>
-              </p:cNvPr>
-              <p:cNvPicPr>
-                <a:picLocks noChangeAspect="1"/>
-              </p:cNvPicPr>
-              <p:nvPr/>
-            </p:nvPicPr>
-            <p:blipFill>
-              <a:blip r:embed="rId19"/>
-              <a:stretch>
-                <a:fillRect/>
-              </a:stretch>
-            </p:blipFill>
-            <p:spPr>
-              <a:xfrm>
-                <a:off x="28184968" y="13194897"/>
-                <a:ext cx="6021336" cy="5853696"/>
-              </a:xfrm>
-              <a:prstGeom prst="rect">
-                <a:avLst/>
-              </a:prstGeom>
-            </p:spPr>
-          </p:pic>
-          <p:pic>
-            <p:nvPicPr>
-              <p:cNvPr id="31" name="Picture 30">
-                <a:extLst>
-                  <a:ext uri="{FF2B5EF4-FFF2-40B4-BE49-F238E27FC236}">
-                    <a16:creationId xmlns:a16="http://schemas.microsoft.com/office/drawing/2014/main" id="{5233663A-D7DC-5130-8EA4-321578E9200D}"/>
-                  </a:ext>
-                </a:extLst>
-              </p:cNvPr>
-              <p:cNvPicPr>
-                <a:picLocks noChangeAspect="1"/>
-              </p:cNvPicPr>
-              <p:nvPr/>
-            </p:nvPicPr>
-            <p:blipFill>
-              <a:blip r:embed="rId20"/>
-              <a:stretch>
-                <a:fillRect/>
-              </a:stretch>
-            </p:blipFill>
-            <p:spPr>
-              <a:xfrm>
-                <a:off x="41043446" y="13194897"/>
-                <a:ext cx="9069342" cy="5853696"/>
-              </a:xfrm>
-              <a:prstGeom prst="rect">
-                <a:avLst/>
-              </a:prstGeom>
-            </p:spPr>
-          </p:pic>
-        </p:grpSp>
-      </p:grpSp>
       <p:graphicFrame>
         <p:nvGraphicFramePr>
           <p:cNvPr id="35" name="Table 34">
             <a:extLst>
               <a:ext uri="{FF2B5EF4-FFF2-40B4-BE49-F238E27FC236}">
-                <a16:creationId xmlns:a16="http://schemas.microsoft.com/office/drawing/2014/main" id="{D4AE00E4-EE83-CEA5-40D7-05A7F23B45EC}"/>
+                <a16:creationId xmlns:a16="http://schemas.microsoft.com/office/drawing/2014/main" id="{37BBB70A-F4A5-D9C3-F0DB-6847E57F6C09}"/>
               </a:ext>
             </a:extLst>
           </p:cNvPr>
           <p:cNvGraphicFramePr>
             <a:graphicFrameLocks noGrp="1"/>
           </p:cNvGraphicFramePr>
-          <p:nvPr>
-            <p:extLst>
-              <p:ext uri="{D42A27DB-BD31-4B8C-83A1-F6EECF244321}">
-                <p14:modId xmlns:p14="http://schemas.microsoft.com/office/powerpoint/2010/main" val="778393713"/>
-              </p:ext>
-            </p:extLst>
-          </p:nvPr>
+          <p:nvPr/>
         </p:nvGraphicFramePr>
         <p:xfrm>
           <a:off x="36377481" y="20820926"/>
@@ -13887,7 +13367,7 @@
           <p:cNvPr id="37" name="Picture 36">
             <a:extLst>
               <a:ext uri="{FF2B5EF4-FFF2-40B4-BE49-F238E27FC236}">
-                <a16:creationId xmlns:a16="http://schemas.microsoft.com/office/drawing/2014/main" id="{584F87D8-BDF9-4F95-914D-EA8A1801D8DD}"/>
+                <a16:creationId xmlns:a16="http://schemas.microsoft.com/office/drawing/2014/main" id="{8786DF91-EC84-E88B-4409-40B17E854B88}"/>
               </a:ext>
             </a:extLst>
           </p:cNvPr>
@@ -13897,7 +13377,7 @@
           <p:nvPr/>
         </p:nvPicPr>
         <p:blipFill>
-          <a:blip r:embed="rId21"/>
+          <a:blip r:embed="rId11"/>
           <a:stretch>
             <a:fillRect/>
           </a:stretch>
@@ -13912,10 +13392,279 @@
           </a:prstGeom>
         </p:spPr>
       </p:pic>
+      <p:grpSp>
+        <p:nvGrpSpPr>
+          <p:cNvPr id="19" name="Group 18">
+            <a:extLst>
+              <a:ext uri="{FF2B5EF4-FFF2-40B4-BE49-F238E27FC236}">
+                <a16:creationId xmlns:a16="http://schemas.microsoft.com/office/drawing/2014/main" id="{056B8BD3-DFEB-913A-F362-7892D1B7765F}"/>
+              </a:ext>
+            </a:extLst>
+          </p:cNvPr>
+          <p:cNvGrpSpPr/>
+          <p:nvPr/>
+        </p:nvGrpSpPr>
+        <p:grpSpPr>
+          <a:xfrm>
+            <a:off x="14524832" y="3292101"/>
+            <a:ext cx="15489936" cy="18595612"/>
+            <a:chOff x="14562120" y="3348494"/>
+            <a:chExt cx="15489936" cy="18595612"/>
+          </a:xfrm>
+        </p:grpSpPr>
+        <p:sp>
+          <p:nvSpPr>
+            <p:cNvPr id="5" name="Arrow: Down 4">
+              <a:extLst>
+                <a:ext uri="{FF2B5EF4-FFF2-40B4-BE49-F238E27FC236}">
+                  <a16:creationId xmlns:a16="http://schemas.microsoft.com/office/drawing/2014/main" id="{568FB863-95BF-4630-2C7C-EEA2FD7CABA7}"/>
+                </a:ext>
+              </a:extLst>
+            </p:cNvPr>
+            <p:cNvSpPr/>
+            <p:nvPr/>
+          </p:nvSpPr>
+          <p:spPr>
+            <a:xfrm>
+              <a:off x="21479774" y="15383367"/>
+              <a:ext cx="1654628" cy="1689382"/>
+            </a:xfrm>
+            <a:prstGeom prst="downArrow">
+              <a:avLst/>
+            </a:prstGeom>
+            <a:solidFill>
+              <a:schemeClr val="bg1"/>
+            </a:solidFill>
+          </p:spPr>
+          <p:style>
+            <a:lnRef idx="2">
+              <a:schemeClr val="accent1">
+                <a:shade val="15000"/>
+              </a:schemeClr>
+            </a:lnRef>
+            <a:fillRef idx="1">
+              <a:schemeClr val="accent1"/>
+            </a:fillRef>
+            <a:effectRef idx="0">
+              <a:schemeClr val="accent1"/>
+            </a:effectRef>
+            <a:fontRef idx="minor">
+              <a:schemeClr val="lt1"/>
+            </a:fontRef>
+          </p:style>
+          <p:txBody>
+            <a:bodyPr rtlCol="0" anchor="ctr"/>
+            <a:lstStyle/>
+            <a:p>
+              <a:pPr algn="ctr"/>
+              <a:endParaRPr lang="en-US"/>
+            </a:p>
+          </p:txBody>
+        </p:sp>
+        <p:sp>
+          <p:nvSpPr>
+            <p:cNvPr id="6" name="Plus Sign 5">
+              <a:extLst>
+                <a:ext uri="{FF2B5EF4-FFF2-40B4-BE49-F238E27FC236}">
+                  <a16:creationId xmlns:a16="http://schemas.microsoft.com/office/drawing/2014/main" id="{CA1FDE7C-8842-489B-AA93-2FB276EC0165}"/>
+                </a:ext>
+              </a:extLst>
+            </p:cNvPr>
+            <p:cNvSpPr/>
+            <p:nvPr/>
+          </p:nvSpPr>
+          <p:spPr>
+            <a:xfrm>
+              <a:off x="21327374" y="8327509"/>
+              <a:ext cx="1959428" cy="1939293"/>
+            </a:xfrm>
+            <a:prstGeom prst="mathPlus">
+              <a:avLst/>
+            </a:prstGeom>
+            <a:solidFill>
+              <a:schemeClr val="bg1"/>
+            </a:solidFill>
+          </p:spPr>
+          <p:style>
+            <a:lnRef idx="2">
+              <a:schemeClr val="accent1">
+                <a:shade val="15000"/>
+              </a:schemeClr>
+            </a:lnRef>
+            <a:fillRef idx="1">
+              <a:schemeClr val="accent1"/>
+            </a:fillRef>
+            <a:effectRef idx="0">
+              <a:schemeClr val="accent1"/>
+            </a:effectRef>
+            <a:fontRef idx="minor">
+              <a:schemeClr val="lt1"/>
+            </a:fontRef>
+          </p:style>
+          <p:txBody>
+            <a:bodyPr rtlCol="0" anchor="ctr"/>
+            <a:lstStyle/>
+            <a:p>
+              <a:pPr algn="ctr"/>
+              <a:endParaRPr lang="en-US"/>
+            </a:p>
+          </p:txBody>
+        </p:sp>
+        <p:pic>
+          <p:nvPicPr>
+            <p:cNvPr id="8" name="Picture 7">
+              <a:extLst>
+                <a:ext uri="{FF2B5EF4-FFF2-40B4-BE49-F238E27FC236}">
+                  <a16:creationId xmlns:a16="http://schemas.microsoft.com/office/drawing/2014/main" id="{D85C61E1-D937-EE24-EE11-EE654FEC001A}"/>
+                </a:ext>
+              </a:extLst>
+            </p:cNvPr>
+            <p:cNvPicPr>
+              <a:picLocks noChangeAspect="1"/>
+            </p:cNvPicPr>
+            <p:nvPr/>
+          </p:nvPicPr>
+          <p:blipFill>
+            <a:blip r:embed="rId12"/>
+            <a:stretch>
+              <a:fillRect/>
+            </a:stretch>
+          </p:blipFill>
+          <p:spPr>
+            <a:xfrm>
+              <a:off x="14562554" y="3348494"/>
+              <a:ext cx="15489069" cy="4774930"/>
+            </a:xfrm>
+            <a:prstGeom prst="rect">
+              <a:avLst/>
+            </a:prstGeom>
+          </p:spPr>
+        </p:pic>
+        <p:pic>
+          <p:nvPicPr>
+            <p:cNvPr id="10" name="Picture 9">
+              <a:extLst>
+                <a:ext uri="{FF2B5EF4-FFF2-40B4-BE49-F238E27FC236}">
+                  <a16:creationId xmlns:a16="http://schemas.microsoft.com/office/drawing/2014/main" id="{3D69892E-50DF-ADDB-E945-4B13417068CD}"/>
+                </a:ext>
+              </a:extLst>
+            </p:cNvPr>
+            <p:cNvPicPr>
+              <a:picLocks noChangeAspect="1"/>
+            </p:cNvPicPr>
+            <p:nvPr/>
+          </p:nvPicPr>
+          <p:blipFill>
+            <a:blip r:embed="rId13"/>
+            <a:stretch>
+              <a:fillRect/>
+            </a:stretch>
+          </p:blipFill>
+          <p:spPr>
+            <a:xfrm>
+              <a:off x="14562120" y="10470887"/>
+              <a:ext cx="15489936" cy="4708395"/>
+            </a:xfrm>
+            <a:prstGeom prst="rect">
+              <a:avLst/>
+            </a:prstGeom>
+          </p:spPr>
+        </p:pic>
+        <p:pic>
+          <p:nvPicPr>
+            <p:cNvPr id="17" name="Picture 16">
+              <a:extLst>
+                <a:ext uri="{FF2B5EF4-FFF2-40B4-BE49-F238E27FC236}">
+                  <a16:creationId xmlns:a16="http://schemas.microsoft.com/office/drawing/2014/main" id="{43657937-8484-AC48-F175-1CFA794C53F6}"/>
+                </a:ext>
+              </a:extLst>
+            </p:cNvPr>
+            <p:cNvPicPr>
+              <a:picLocks noChangeAspect="1"/>
+            </p:cNvPicPr>
+            <p:nvPr/>
+          </p:nvPicPr>
+          <p:blipFill>
+            <a:blip r:embed="rId14"/>
+            <a:stretch>
+              <a:fillRect/>
+            </a:stretch>
+          </p:blipFill>
+          <p:spPr>
+            <a:xfrm>
+              <a:off x="14562120" y="17276833"/>
+              <a:ext cx="15489936" cy="4667273"/>
+            </a:xfrm>
+            <a:prstGeom prst="rect">
+              <a:avLst/>
+            </a:prstGeom>
+          </p:spPr>
+        </p:pic>
+      </p:grpSp>
+      <p:pic>
+        <p:nvPicPr>
+          <p:cNvPr id="29" name="Picture 28">
+            <a:extLst>
+              <a:ext uri="{FF2B5EF4-FFF2-40B4-BE49-F238E27FC236}">
+                <a16:creationId xmlns:a16="http://schemas.microsoft.com/office/drawing/2014/main" id="{2B74D41B-8766-F746-83EB-77C820E9020D}"/>
+              </a:ext>
+            </a:extLst>
+          </p:cNvPr>
+          <p:cNvPicPr>
+            <a:picLocks noChangeAspect="1"/>
+          </p:cNvPicPr>
+          <p:nvPr/>
+        </p:nvPicPr>
+        <p:blipFill>
+          <a:blip r:embed="rId15"/>
+          <a:stretch>
+            <a:fillRect/>
+          </a:stretch>
+        </p:blipFill>
+        <p:spPr>
+          <a:xfrm>
+            <a:off x="14534559" y="25997867"/>
+            <a:ext cx="15538340" cy="3796549"/>
+          </a:xfrm>
+          <a:prstGeom prst="rect">
+            <a:avLst/>
+          </a:prstGeom>
+        </p:spPr>
+      </p:pic>
+      <p:pic>
+        <p:nvPicPr>
+          <p:cNvPr id="33" name="Picture 32">
+            <a:extLst>
+              <a:ext uri="{FF2B5EF4-FFF2-40B4-BE49-F238E27FC236}">
+                <a16:creationId xmlns:a16="http://schemas.microsoft.com/office/drawing/2014/main" id="{5FF8CA07-FBE4-4D3D-738B-ADFB5B3928E2}"/>
+              </a:ext>
+            </a:extLst>
+          </p:cNvPr>
+          <p:cNvPicPr>
+            <a:picLocks noChangeAspect="1"/>
+          </p:cNvPicPr>
+          <p:nvPr/>
+        </p:nvPicPr>
+        <p:blipFill>
+          <a:blip r:embed="rId16"/>
+          <a:stretch>
+            <a:fillRect/>
+          </a:stretch>
+        </p:blipFill>
+        <p:spPr>
+          <a:xfrm>
+            <a:off x="30473573" y="6030625"/>
+            <a:ext cx="12545568" cy="6422646"/>
+          </a:xfrm>
+          <a:prstGeom prst="rect">
+            <a:avLst/>
+          </a:prstGeom>
+        </p:spPr>
+      </p:pic>
     </p:spTree>
     <p:extLst>
       <p:ext uri="{BB962C8B-B14F-4D97-AF65-F5344CB8AC3E}">
-        <p14:creationId xmlns:p14="http://schemas.microsoft.com/office/powerpoint/2010/main" val="2613147916"/>
+        <p14:creationId xmlns:p14="http://schemas.microsoft.com/office/powerpoint/2010/main" val="2835064842"/>
       </p:ext>
     </p:extLst>
   </p:cSld>

</xml_diff>